<commit_message>
WIP: snapshot of lessons being written by running batches (unreviewed)
Co-Authored-By: Claude Opus 5.5 <noreply@anthropic.com>
Claude-Session: https://claude.ai/code/session_01EDFMZ4KdXfygs8AmnQ2tjw
</commit_message>
<xml_diff>
--- a/dist/초1/국어/한글/초1_국어_한글_01_기본모음.pptx
+++ b/dist/초1/국어/한글/초1_국어_한글_01_기본모음.pptx
@@ -120,20 +120,20 @@
   <p:extLst>
     <p:ext uri="{521415D9-36F7-43E2-AB2F-B90AF26B5E84}">
       <p14:sectionLst xmlns:p14="http://schemas.microsoft.com/office/powerpoint/2010/main">
-        <p14:section name="도입" id="{55e72f5e-75e7-bc14-e391-87fa1a2b7189}">
+        <p14:section name="도입" id="{d9bfd5a7-e589-ec33-8935-880fee19969b}">
           <p14:sldIdLst>
             <p14:sldId id="256"/>
             <p14:sldId id="257"/>
           </p14:sldIdLst>
         </p14:section>
-        <p14:section name="개념" id="{23d946be-1aab-b45f-ba08-c3cf3254b033}">
+        <p14:section name="개념" id="{b58cccc7-1eb9-6434-f6a6-c304dd1bdfb6}">
           <p14:sldIdLst>
             <p14:sldId id="258"/>
             <p14:sldId id="259"/>
             <p14:sldId id="260"/>
           </p14:sldIdLst>
         </p14:section>
-        <p14:section name="연습" id="{5223cdea-ba24-2270-4c07-07d8ae448466}">
+        <p14:section name="연습" id="{f38f1b16-ffe4-199f-23bc-c3a601f359c5}">
           <p14:sldIdLst>
             <p14:sldId id="261"/>
             <p14:sldId id="262"/>
@@ -141,19 +141,19 @@
             <p14:sldId id="264"/>
           </p14:sldIdLst>
         </p14:section>
-        <p14:section name="확인" id="{16662bf6-17c1-7476-84fb-15d5f95c04af}">
+        <p14:section name="확인" id="{e0712e71-6b09-fc58-c198-b3edc383d2b7}">
           <p14:sldIdLst>
             <p14:sldId id="265"/>
             <p14:sldId id="266"/>
             <p14:sldId id="267"/>
           </p14:sldIdLst>
         </p14:section>
-        <p14:section name="정리" id="{a2efa506-d06c-912f-51a8-1b6574daeb72}">
+        <p14:section name="정리" id="{01c3a449-bf8d-ce01-a776-69b3eb481507}">
           <p14:sldIdLst>
             <p14:sldId id="268"/>
           </p14:sldIdLst>
         </p14:section>
-        <p14:section name="보충" id="{dfd4ab37-b6ab-0d4b-0c19-c0cd8893a3d2}">
+        <p14:section name="보충" id="{cedf9a3e-eec9-24ca-1ad7-8981e36644ad}">
           <p14:sldIdLst>
             <p14:sldId id="269"/>
           </p14:sldIdLst>
@@ -1870,7 +1870,8 @@
 - ④ ㅠ: ㅡ → 왼쪽 막대 → 오른쪽 막대 [유]
 막히면
 - S08의 ㅏ, ㅓ, ㅗ, ㅜ를 먼저 한 번 더 쓰고, 짧은 막대를 하나씩 더하게 합니다.
-- 활동지 글자를 손가락으로 먼저 덧그린 뒤 연필로 씁니다.</a:t>
+- 활동지 글자를 손가락으로 먼저 덧그린 뒤 연필로 씁니다.
+- 활동지 글자가 작게 느껴지면 부모가 빈 종이에 크게 써 주고 따라 쓰게 합니다.</a:t>
             </a:r>
             <a:endParaRPr lang="en-US" dirty="0"/>
           </a:p>

</xml_diff>